<commit_message>
Update presentation and analysis files with revised content
</commit_message>
<xml_diff>
--- a/プレゼンテーション.pptx
+++ b/プレゼンテーション.pptx
@@ -718,7 +718,7 @@
           <a:p>
             <a:fld id="{164B3D7D-398B-0445-A1E4-13E0BD7D0987}" type="datetimeFigureOut">
               <a:rPr kumimoji="1" lang="ja-JP" altLang="en-US" smtClean="0"/>
-              <a:t>2026/7/6</a:t>
+              <a:t>2026/7/2</a:t>
             </a:fld>
             <a:endParaRPr kumimoji="1" lang="ja-JP" altLang="en-US"/>
           </a:p>
@@ -948,7 +948,7 @@
           <a:p>
             <a:fld id="{164B3D7D-398B-0445-A1E4-13E0BD7D0987}" type="datetimeFigureOut">
               <a:rPr kumimoji="1" lang="ja-JP" altLang="en-US" smtClean="0"/>
-              <a:t>2026/7/6</a:t>
+              <a:t>2026/7/2</a:t>
             </a:fld>
             <a:endParaRPr kumimoji="1" lang="ja-JP" altLang="en-US"/>
           </a:p>
@@ -1188,7 +1188,7 @@
           <a:p>
             <a:fld id="{164B3D7D-398B-0445-A1E4-13E0BD7D0987}" type="datetimeFigureOut">
               <a:rPr kumimoji="1" lang="ja-JP" altLang="en-US" smtClean="0"/>
-              <a:t>2026/7/6</a:t>
+              <a:t>2026/7/2</a:t>
             </a:fld>
             <a:endParaRPr kumimoji="1" lang="ja-JP" altLang="en-US"/>
           </a:p>
@@ -1425,7 +1425,7 @@
           <a:p>
             <a:fld id="{164B3D7D-398B-0445-A1E4-13E0BD7D0987}" type="datetimeFigureOut">
               <a:rPr kumimoji="1" lang="ja-JP" altLang="en-US" smtClean="0"/>
-              <a:t>2026/7/6</a:t>
+              <a:t>2026/7/2</a:t>
             </a:fld>
             <a:endParaRPr kumimoji="1" lang="ja-JP" altLang="en-US"/>
           </a:p>
@@ -1703,7 +1703,7 @@
           <a:p>
             <a:fld id="{164B3D7D-398B-0445-A1E4-13E0BD7D0987}" type="datetimeFigureOut">
               <a:rPr kumimoji="1" lang="ja-JP" altLang="en-US" smtClean="0"/>
-              <a:t>2026/7/6</a:t>
+              <a:t>2026/7/2</a:t>
             </a:fld>
             <a:endParaRPr kumimoji="1" lang="ja-JP" altLang="en-US"/>
           </a:p>
@@ -2032,7 +2032,7 @@
           <a:p>
             <a:fld id="{164B3D7D-398B-0445-A1E4-13E0BD7D0987}" type="datetimeFigureOut">
               <a:rPr kumimoji="1" lang="ja-JP" altLang="en-US" smtClean="0"/>
-              <a:t>2026/7/6</a:t>
+              <a:t>2026/7/2</a:t>
             </a:fld>
             <a:endParaRPr kumimoji="1" lang="ja-JP" altLang="en-US"/>
           </a:p>
@@ -2508,7 +2508,7 @@
           <a:p>
             <a:fld id="{164B3D7D-398B-0445-A1E4-13E0BD7D0987}" type="datetimeFigureOut">
               <a:rPr kumimoji="1" lang="ja-JP" altLang="en-US" smtClean="0"/>
-              <a:t>2026/7/6</a:t>
+              <a:t>2026/7/2</a:t>
             </a:fld>
             <a:endParaRPr kumimoji="1" lang="ja-JP" altLang="en-US"/>
           </a:p>
@@ -2649,7 +2649,7 @@
           <a:p>
             <a:fld id="{164B3D7D-398B-0445-A1E4-13E0BD7D0987}" type="datetimeFigureOut">
               <a:rPr kumimoji="1" lang="ja-JP" altLang="en-US" smtClean="0"/>
-              <a:t>2026/7/6</a:t>
+              <a:t>2026/7/2</a:t>
             </a:fld>
             <a:endParaRPr kumimoji="1" lang="ja-JP" altLang="en-US"/>
           </a:p>
@@ -2762,7 +2762,7 @@
           <a:p>
             <a:fld id="{164B3D7D-398B-0445-A1E4-13E0BD7D0987}" type="datetimeFigureOut">
               <a:rPr kumimoji="1" lang="ja-JP" altLang="en-US" smtClean="0"/>
-              <a:t>2026/7/6</a:t>
+              <a:t>2026/7/2</a:t>
             </a:fld>
             <a:endParaRPr kumimoji="1" lang="ja-JP" altLang="en-US"/>
           </a:p>
@@ -3105,7 +3105,7 @@
           <a:p>
             <a:fld id="{164B3D7D-398B-0445-A1E4-13E0BD7D0987}" type="datetimeFigureOut">
               <a:rPr kumimoji="1" lang="ja-JP" altLang="en-US" smtClean="0"/>
-              <a:t>2026/7/6</a:t>
+              <a:t>2026/7/2</a:t>
             </a:fld>
             <a:endParaRPr kumimoji="1" lang="ja-JP" altLang="en-US"/>
           </a:p>
@@ -3393,7 +3393,7 @@
           <a:p>
             <a:fld id="{164B3D7D-398B-0445-A1E4-13E0BD7D0987}" type="datetimeFigureOut">
               <a:rPr kumimoji="1" lang="ja-JP" altLang="en-US" smtClean="0"/>
-              <a:t>2026/7/6</a:t>
+              <a:t>2026/7/2</a:t>
             </a:fld>
             <a:endParaRPr kumimoji="1" lang="ja-JP" altLang="en-US"/>
           </a:p>
@@ -3666,7 +3666,7 @@
           <a:p>
             <a:fld id="{164B3D7D-398B-0445-A1E4-13E0BD7D0987}" type="datetimeFigureOut">
               <a:rPr kumimoji="1" lang="ja-JP" altLang="en-US" smtClean="0"/>
-              <a:t>2026/7/6</a:t>
+              <a:t>2026/7/2</a:t>
             </a:fld>
             <a:endParaRPr kumimoji="1" lang="ja-JP" altLang="en-US"/>
           </a:p>
@@ -4105,9 +4105,10 @@
           <a:lstStyle/>
           <a:p>
             <a:r>
-              <a:rPr kumimoji="1" lang="ja-JP" altLang="en-US"/>
-              <a:t>人口密度</a:t>
-            </a:r>
+              <a:rPr kumimoji="1" lang="en-US" altLang="ja-JP" dirty="0" err="1"/>
+              <a:t>aaaaaa</a:t>
+            </a:r>
+            <a:endParaRPr kumimoji="1" lang="ja-JP" altLang="en-US"/>
           </a:p>
         </p:txBody>
       </p:sp>
@@ -5285,16 +5286,10 @@
           <a:lstStyle/>
           <a:p>
             <a:r>
-              <a:rPr kumimoji="1" lang="ja-JP" altLang="en-US" sz="2400">
-                <a:latin typeface="Yu Gothic" panose="020B0400000000000000" pitchFamily="34" charset="-128"/>
-                <a:ea typeface="Yu Gothic" panose="020B0400000000000000" pitchFamily="34" charset="-128"/>
-              </a:rPr>
+              <a:rPr kumimoji="1" lang="ja-JP" altLang="en-US" sz="2400"/>
               <a:t>外国人人口</a:t>
             </a:r>
-            <a:endParaRPr lang="en-US" altLang="ja-JP" sz="2400" dirty="0">
-              <a:latin typeface="Yu Gothic" panose="020B0400000000000000" pitchFamily="34" charset="-128"/>
-              <a:ea typeface="Yu Gothic" panose="020B0400000000000000" pitchFamily="34" charset="-128"/>
-            </a:endParaRPr>
+            <a:endParaRPr lang="en-US" altLang="ja-JP" sz="2400" dirty="0"/>
           </a:p>
           <a:p>
             <a:r>
@@ -5302,8 +5297,7 @@
                 <a:solidFill>
                   <a:srgbClr val="000000"/>
                 </a:solidFill>
-                <a:latin typeface="Yu Gothic" panose="020B0400000000000000" pitchFamily="34" charset="-128"/>
-                <a:ea typeface="Yu Gothic" panose="020B0400000000000000" pitchFamily="34" charset="-128"/>
+                <a:latin typeface="Gen Interface JP"/>
               </a:rPr>
               <a:t>事業所数（民営）（農業、林業）</a:t>
             </a:r>
@@ -5311,8 +5305,7 @@
               <a:solidFill>
                 <a:srgbClr val="000000"/>
               </a:solidFill>
-              <a:latin typeface="Yu Gothic" panose="020B0400000000000000" pitchFamily="34" charset="-128"/>
-              <a:ea typeface="Yu Gothic" panose="020B0400000000000000" pitchFamily="34" charset="-128"/>
+              <a:latin typeface="Gen Interface JP"/>
             </a:endParaRPr>
           </a:p>
           <a:p>
@@ -5321,8 +5314,7 @@
                 <a:solidFill>
                   <a:srgbClr val="000000"/>
                 </a:solidFill>
-                <a:latin typeface="Yu Gothic" panose="020B0400000000000000" pitchFamily="34" charset="-128"/>
-                <a:ea typeface="Yu Gothic" panose="020B0400000000000000" pitchFamily="34" charset="-128"/>
+                <a:latin typeface="Gen Interface JP"/>
               </a:rPr>
               <a:t>歳出</a:t>
             </a:r>
@@ -5331,8 +5323,7 @@
                 <a:solidFill>
                   <a:srgbClr val="000000"/>
                 </a:solidFill>
-                <a:latin typeface="Yu Gothic" panose="020B0400000000000000" pitchFamily="34" charset="-128"/>
-                <a:ea typeface="Yu Gothic" panose="020B0400000000000000" pitchFamily="34" charset="-128"/>
+                <a:latin typeface="Gen Interface JP"/>
               </a:rPr>
               <a:t>決算総額（市町村財政）</a:t>
             </a:r>
@@ -5340,8 +5331,7 @@
               <a:solidFill>
                 <a:srgbClr val="000000"/>
               </a:solidFill>
-              <a:latin typeface="Yu Gothic" panose="020B0400000000000000" pitchFamily="34" charset="-128"/>
-              <a:ea typeface="Yu Gothic" panose="020B0400000000000000" pitchFamily="34" charset="-128"/>
+              <a:latin typeface="Gen Interface JP"/>
             </a:endParaRPr>
           </a:p>
           <a:p>
@@ -5350,8 +5340,7 @@
                 <a:solidFill>
                   <a:srgbClr val="000000"/>
                 </a:solidFill>
-                <a:latin typeface="Yu Gothic" panose="020B0400000000000000" pitchFamily="34" charset="-128"/>
-                <a:ea typeface="Yu Gothic" panose="020B0400000000000000" pitchFamily="34" charset="-128"/>
+                <a:latin typeface="Gen Interface JP"/>
               </a:rPr>
               <a:t>民生費（市町村財政）</a:t>
             </a:r>
@@ -5359,8 +5348,7 @@
               <a:solidFill>
                 <a:srgbClr val="000000"/>
               </a:solidFill>
-              <a:latin typeface="Yu Gothic" panose="020B0400000000000000" pitchFamily="34" charset="-128"/>
-              <a:ea typeface="Yu Gothic" panose="020B0400000000000000" pitchFamily="34" charset="-128"/>
+              <a:latin typeface="Gen Interface JP"/>
             </a:endParaRPr>
           </a:p>
           <a:p>
@@ -5369,8 +5357,7 @@
                 <a:solidFill>
                   <a:srgbClr val="000000"/>
                 </a:solidFill>
-                <a:latin typeface="Yu Gothic" panose="020B0400000000000000" pitchFamily="34" charset="-128"/>
-                <a:ea typeface="Yu Gothic" panose="020B0400000000000000" pitchFamily="34" charset="-128"/>
+                <a:latin typeface="Gen Interface JP"/>
               </a:rPr>
               <a:t>幼稚園在園者数</a:t>
             </a:r>
@@ -5378,8 +5365,7 @@
               <a:solidFill>
                 <a:srgbClr val="000000"/>
               </a:solidFill>
-              <a:latin typeface="Yu Gothic" panose="020B0400000000000000" pitchFamily="34" charset="-128"/>
-              <a:ea typeface="Yu Gothic" panose="020B0400000000000000" pitchFamily="34" charset="-128"/>
+              <a:latin typeface="Gen Interface JP"/>
             </a:endParaRPr>
           </a:p>
           <a:p>
@@ -5388,8 +5374,7 @@
                 <a:solidFill>
                   <a:srgbClr val="000000"/>
                 </a:solidFill>
-                <a:latin typeface="Yu Gothic" panose="020B0400000000000000" pitchFamily="34" charset="-128"/>
-                <a:ea typeface="Yu Gothic" panose="020B0400000000000000" pitchFamily="34" charset="-128"/>
+                <a:latin typeface="Gen Interface JP"/>
               </a:rPr>
               <a:t>高等学校生徒数</a:t>
             </a:r>
@@ -5397,8 +5382,7 @@
               <a:solidFill>
                 <a:srgbClr val="000000"/>
               </a:solidFill>
-              <a:latin typeface="Yu Gothic" panose="020B0400000000000000" pitchFamily="34" charset="-128"/>
-              <a:ea typeface="Yu Gothic" panose="020B0400000000000000" pitchFamily="34" charset="-128"/>
+              <a:latin typeface="Gen Interface JP"/>
             </a:endParaRPr>
           </a:p>
           <a:p>
@@ -5407,8 +5391,7 @@
                 <a:solidFill>
                   <a:srgbClr val="000000"/>
                 </a:solidFill>
-                <a:latin typeface="Yu Gothic" panose="020B0400000000000000" pitchFamily="34" charset="-128"/>
-                <a:ea typeface="Yu Gothic" panose="020B0400000000000000" pitchFamily="34" charset="-128"/>
+                <a:latin typeface="Gen Interface JP"/>
               </a:rPr>
               <a:t>第３次産業就業者数</a:t>
             </a:r>
@@ -5416,8 +5399,7 @@
               <a:solidFill>
                 <a:srgbClr val="000000"/>
               </a:solidFill>
-              <a:latin typeface="Yu Gothic" panose="020B0400000000000000" pitchFamily="34" charset="-128"/>
-              <a:ea typeface="Yu Gothic" panose="020B0400000000000000" pitchFamily="34" charset="-128"/>
+              <a:latin typeface="Gen Interface JP"/>
             </a:endParaRPr>
           </a:p>
           <a:p>
@@ -5426,8 +5408,7 @@
                 <a:solidFill>
                   <a:srgbClr val="000000"/>
                 </a:solidFill>
-                <a:latin typeface="Yu Gothic" panose="020B0400000000000000" pitchFamily="34" charset="-128"/>
-                <a:ea typeface="Yu Gothic" panose="020B0400000000000000" pitchFamily="34" charset="-128"/>
+                <a:latin typeface="Gen Interface JP"/>
               </a:rPr>
               <a:t>p15歳未満人口</a:t>
             </a:r>
@@ -5435,8 +5416,7 @@
               <a:solidFill>
                 <a:srgbClr val="000000"/>
               </a:solidFill>
-              <a:latin typeface="Yu Gothic" panose="020B0400000000000000" pitchFamily="34" charset="-128"/>
-              <a:ea typeface="Yu Gothic" panose="020B0400000000000000" pitchFamily="34" charset="-128"/>
+              <a:latin typeface="Gen Interface JP"/>
             </a:endParaRPr>
           </a:p>
         </p:txBody>
@@ -5638,8 +5618,7 @@
                 <a:solidFill>
                   <a:srgbClr val="000000"/>
                 </a:solidFill>
-                <a:latin typeface="Yu Gothic" panose="020B0400000000000000" pitchFamily="34" charset="-128"/>
-                <a:ea typeface="Yu Gothic" panose="020B0400000000000000" pitchFamily="34" charset="-128"/>
+                <a:latin typeface="Gen Interface JP"/>
               </a:rPr>
               <a:t>p65歳以上の世帯員のいる核家族世帯数</a:t>
             </a:r>
@@ -5647,8 +5626,7 @@
               <a:solidFill>
                 <a:srgbClr val="000000"/>
               </a:solidFill>
-              <a:latin typeface="Yu Gothic" panose="020B0400000000000000" pitchFamily="34" charset="-128"/>
-              <a:ea typeface="Yu Gothic" panose="020B0400000000000000" pitchFamily="34" charset="-128"/>
+              <a:latin typeface="Gen Interface JP"/>
             </a:endParaRPr>
           </a:p>
           <a:p>
@@ -5657,8 +5635,7 @@
                 <a:solidFill>
                   <a:srgbClr val="000000"/>
                 </a:solidFill>
-                <a:latin typeface="Yu Gothic" panose="020B0400000000000000" pitchFamily="34" charset="-128"/>
-                <a:ea typeface="Yu Gothic" panose="020B0400000000000000" pitchFamily="34" charset="-128"/>
+                <a:latin typeface="Gen Interface JP"/>
               </a:rPr>
               <a:t>p従業者数（民営）（卸売業、小売業）p農家数（自給的農家）</a:t>
             </a:r>
@@ -5666,8 +5643,7 @@
               <a:solidFill>
                 <a:srgbClr val="000000"/>
               </a:solidFill>
-              <a:latin typeface="Yu Gothic" panose="020B0400000000000000" pitchFamily="34" charset="-128"/>
-              <a:ea typeface="Yu Gothic" panose="020B0400000000000000" pitchFamily="34" charset="-128"/>
+              <a:latin typeface="Gen Interface JP"/>
             </a:endParaRPr>
           </a:p>
           <a:p>
@@ -5676,8 +5652,7 @@
                 <a:solidFill>
                   <a:srgbClr val="000000"/>
                 </a:solidFill>
-                <a:latin typeface="Yu Gothic" panose="020B0400000000000000" pitchFamily="34" charset="-128"/>
-                <a:ea typeface="Yu Gothic" panose="020B0400000000000000" pitchFamily="34" charset="-128"/>
+                <a:latin typeface="Gen Interface JP"/>
               </a:rPr>
               <a:t>p従業者数（民営）（医療、福祉）</a:t>
             </a:r>
@@ -5685,8 +5660,7 @@
               <a:solidFill>
                 <a:srgbClr val="000000"/>
               </a:solidFill>
-              <a:latin typeface="Yu Gothic" panose="020B0400000000000000" pitchFamily="34" charset="-128"/>
-              <a:ea typeface="Yu Gothic" panose="020B0400000000000000" pitchFamily="34" charset="-128"/>
+              <a:latin typeface="Gen Interface JP"/>
             </a:endParaRPr>
           </a:p>
           <a:p>
@@ -5695,8 +5669,7 @@
                 <a:solidFill>
                   <a:srgbClr val="000000"/>
                 </a:solidFill>
-                <a:latin typeface="Yu Gothic" panose="020B0400000000000000" pitchFamily="34" charset="-128"/>
-                <a:ea typeface="Yu Gothic" panose="020B0400000000000000" pitchFamily="34" charset="-128"/>
+                <a:latin typeface="Gen Interface JP"/>
               </a:rPr>
               <a:t>p歳出決算総額（市町村財政）</a:t>
             </a:r>
@@ -5704,8 +5677,7 @@
               <a:solidFill>
                 <a:srgbClr val="000000"/>
               </a:solidFill>
-              <a:latin typeface="Yu Gothic" panose="020B0400000000000000" pitchFamily="34" charset="-128"/>
-              <a:ea typeface="Yu Gothic" panose="020B0400000000000000" pitchFamily="34" charset="-128"/>
+              <a:latin typeface="Gen Interface JP"/>
             </a:endParaRPr>
           </a:p>
           <a:p>
@@ -5714,8 +5686,7 @@
                 <a:solidFill>
                   <a:srgbClr val="000000"/>
                 </a:solidFill>
-                <a:latin typeface="Yu Gothic" panose="020B0400000000000000" pitchFamily="34" charset="-128"/>
-                <a:ea typeface="Yu Gothic" panose="020B0400000000000000" pitchFamily="34" charset="-128"/>
+                <a:latin typeface="Gen Interface JP"/>
               </a:rPr>
               <a:t>p第１次産業就業者数</a:t>
             </a:r>
@@ -5723,8 +5694,7 @@
               <a:solidFill>
                 <a:srgbClr val="000000"/>
               </a:solidFill>
-              <a:latin typeface="Yu Gothic" panose="020B0400000000000000" pitchFamily="34" charset="-128"/>
-              <a:ea typeface="Yu Gothic" panose="020B0400000000000000" pitchFamily="34" charset="-128"/>
+              <a:latin typeface="Gen Interface JP"/>
             </a:endParaRPr>
           </a:p>
           <a:p>
@@ -5733,8 +5703,7 @@
                 <a:solidFill>
                   <a:srgbClr val="000000"/>
                 </a:solidFill>
-                <a:latin typeface="Yu Gothic" panose="020B0400000000000000" pitchFamily="34" charset="-128"/>
-                <a:ea typeface="Yu Gothic" panose="020B0400000000000000" pitchFamily="34" charset="-128"/>
+                <a:latin typeface="Gen Interface JP"/>
               </a:rPr>
               <a:t>p第２次産業就業者数</a:t>
             </a:r>
@@ -5742,8 +5711,7 @@
               <a:solidFill>
                 <a:srgbClr val="000000"/>
               </a:solidFill>
-              <a:latin typeface="Yu Gothic" panose="020B0400000000000000" pitchFamily="34" charset="-128"/>
-              <a:ea typeface="Yu Gothic" panose="020B0400000000000000" pitchFamily="34" charset="-128"/>
+              <a:latin typeface="Gen Interface JP"/>
             </a:endParaRPr>
           </a:p>
           <a:p>
@@ -5752,8 +5720,7 @@
                 <a:solidFill>
                   <a:srgbClr val="000000"/>
                 </a:solidFill>
-                <a:latin typeface="Yu Gothic" panose="020B0400000000000000" pitchFamily="34" charset="-128"/>
-                <a:ea typeface="Yu Gothic" panose="020B0400000000000000" pitchFamily="34" charset="-128"/>
+                <a:latin typeface="Gen Interface JP"/>
               </a:rPr>
               <a:t>p第３次産業就業者数</a:t>
             </a:r>
@@ -5761,8 +5728,7 @@
               <a:solidFill>
                 <a:srgbClr val="000000"/>
               </a:solidFill>
-              <a:latin typeface="Yu Gothic" panose="020B0400000000000000" pitchFamily="34" charset="-128"/>
-              <a:ea typeface="Yu Gothic" panose="020B0400000000000000" pitchFamily="34" charset="-128"/>
+              <a:latin typeface="Gen Interface JP"/>
             </a:endParaRPr>
           </a:p>
           <a:p>
@@ -5771,257 +5737,11 @@
                 <a:solidFill>
                   <a:srgbClr val="000000"/>
                 </a:solidFill>
-                <a:latin typeface="Yu Gothic" panose="020B0400000000000000" pitchFamily="34" charset="-128"/>
-                <a:ea typeface="Yu Gothic" panose="020B0400000000000000" pitchFamily="34" charset="-128"/>
+                <a:latin typeface="Gen Interface JP"/>
               </a:rPr>
               <a:t>p小売店数</a:t>
             </a:r>
-            <a:endParaRPr lang="en-US" altLang="ja-JP" sz="2400" dirty="0">
-              <a:latin typeface="Yu Gothic" panose="020B0400000000000000" pitchFamily="34" charset="-128"/>
-              <a:ea typeface="Yu Gothic" panose="020B0400000000000000" pitchFamily="34" charset="-128"/>
-            </a:endParaRPr>
-          </a:p>
-        </p:txBody>
-      </p:sp>
-      <p:sp>
-        <p:nvSpPr>
-          <p:cNvPr id="5" name="コンテンツ プレースホルダー 2">
-            <a:extLst>
-              <a:ext uri="{FF2B5EF4-FFF2-40B4-BE49-F238E27FC236}">
-                <a16:creationId xmlns:a16="http://schemas.microsoft.com/office/drawing/2014/main" id="{82C1FBE7-44F8-8215-84DB-961300CB5C8E}"/>
-              </a:ext>
-            </a:extLst>
-          </p:cNvPr>
-          <p:cNvSpPr txBox="1">
-            <a:spLocks/>
-          </p:cNvSpPr>
-          <p:nvPr/>
-        </p:nvSpPr>
-        <p:spPr>
-          <a:xfrm>
-            <a:off x="8305800" y="6253878"/>
-            <a:ext cx="3305229" cy="681037"/>
-          </a:xfrm>
-          <a:prstGeom prst="rect">
-            <a:avLst/>
-          </a:prstGeom>
-        </p:spPr>
-        <p:txBody>
-          <a:bodyPr vert="horz" lIns="91440" tIns="45720" rIns="91440" bIns="45720" rtlCol="0">
-            <a:normAutofit/>
-          </a:bodyPr>
-          <a:lstStyle>
-            <a:lvl1pPr marL="228600" indent="-228600" algn="l" defTabSz="914400" rtl="0" eaLnBrk="1" latinLnBrk="0" hangingPunct="1">
-              <a:lnSpc>
-                <a:spcPct val="90000"/>
-              </a:lnSpc>
-              <a:spcBef>
-                <a:spcPts val="1000"/>
-              </a:spcBef>
-              <a:buFont typeface="Arial" panose="020B0604020202020204" pitchFamily="34" charset="0"/>
-              <a:buChar char="•"/>
-              <a:defRPr kumimoji="1" sz="2800" kern="1200">
-                <a:solidFill>
-                  <a:schemeClr val="tx1"/>
-                </a:solidFill>
-                <a:latin typeface="+mn-lt"/>
-                <a:ea typeface="+mn-ea"/>
-                <a:cs typeface="+mn-cs"/>
-              </a:defRPr>
-            </a:lvl1pPr>
-            <a:lvl2pPr marL="685800" indent="-228600" algn="l" defTabSz="914400" rtl="0" eaLnBrk="1" latinLnBrk="0" hangingPunct="1">
-              <a:lnSpc>
-                <a:spcPct val="90000"/>
-              </a:lnSpc>
-              <a:spcBef>
-                <a:spcPts val="500"/>
-              </a:spcBef>
-              <a:buFont typeface="Arial" panose="020B0604020202020204" pitchFamily="34" charset="0"/>
-              <a:buChar char="•"/>
-              <a:defRPr kumimoji="1" sz="2400" kern="1200">
-                <a:solidFill>
-                  <a:schemeClr val="tx1"/>
-                </a:solidFill>
-                <a:latin typeface="+mn-lt"/>
-                <a:ea typeface="+mn-ea"/>
-                <a:cs typeface="+mn-cs"/>
-              </a:defRPr>
-            </a:lvl2pPr>
-            <a:lvl3pPr marL="1143000" indent="-228600" algn="l" defTabSz="914400" rtl="0" eaLnBrk="1" latinLnBrk="0" hangingPunct="1">
-              <a:lnSpc>
-                <a:spcPct val="90000"/>
-              </a:lnSpc>
-              <a:spcBef>
-                <a:spcPts val="500"/>
-              </a:spcBef>
-              <a:buFont typeface="Arial" panose="020B0604020202020204" pitchFamily="34" charset="0"/>
-              <a:buChar char="•"/>
-              <a:defRPr kumimoji="1" sz="2000" kern="1200">
-                <a:solidFill>
-                  <a:schemeClr val="tx1"/>
-                </a:solidFill>
-                <a:latin typeface="+mn-lt"/>
-                <a:ea typeface="+mn-ea"/>
-                <a:cs typeface="+mn-cs"/>
-              </a:defRPr>
-            </a:lvl3pPr>
-            <a:lvl4pPr marL="1600200" indent="-228600" algn="l" defTabSz="914400" rtl="0" eaLnBrk="1" latinLnBrk="0" hangingPunct="1">
-              <a:lnSpc>
-                <a:spcPct val="90000"/>
-              </a:lnSpc>
-              <a:spcBef>
-                <a:spcPts val="500"/>
-              </a:spcBef>
-              <a:buFont typeface="Arial" panose="020B0604020202020204" pitchFamily="34" charset="0"/>
-              <a:buChar char="•"/>
-              <a:defRPr kumimoji="1" sz="1800" kern="1200">
-                <a:solidFill>
-                  <a:schemeClr val="tx1"/>
-                </a:solidFill>
-                <a:latin typeface="+mn-lt"/>
-                <a:ea typeface="+mn-ea"/>
-                <a:cs typeface="+mn-cs"/>
-              </a:defRPr>
-            </a:lvl4pPr>
-            <a:lvl5pPr marL="2057400" indent="-228600" algn="l" defTabSz="914400" rtl="0" eaLnBrk="1" latinLnBrk="0" hangingPunct="1">
-              <a:lnSpc>
-                <a:spcPct val="90000"/>
-              </a:lnSpc>
-              <a:spcBef>
-                <a:spcPts val="500"/>
-              </a:spcBef>
-              <a:buFont typeface="Arial" panose="020B0604020202020204" pitchFamily="34" charset="0"/>
-              <a:buChar char="•"/>
-              <a:defRPr kumimoji="1" sz="1800" kern="1200">
-                <a:solidFill>
-                  <a:schemeClr val="tx1"/>
-                </a:solidFill>
-                <a:latin typeface="+mn-lt"/>
-                <a:ea typeface="+mn-ea"/>
-                <a:cs typeface="+mn-cs"/>
-              </a:defRPr>
-            </a:lvl5pPr>
-            <a:lvl6pPr marL="2514600" indent="-228600" algn="l" defTabSz="914400" rtl="0" eaLnBrk="1" latinLnBrk="0" hangingPunct="1">
-              <a:lnSpc>
-                <a:spcPct val="90000"/>
-              </a:lnSpc>
-              <a:spcBef>
-                <a:spcPts val="500"/>
-              </a:spcBef>
-              <a:buFont typeface="Arial" panose="020B0604020202020204" pitchFamily="34" charset="0"/>
-              <a:buChar char="•"/>
-              <a:defRPr kumimoji="1" sz="1800" kern="1200">
-                <a:solidFill>
-                  <a:schemeClr val="tx1"/>
-                </a:solidFill>
-                <a:latin typeface="+mn-lt"/>
-                <a:ea typeface="+mn-ea"/>
-                <a:cs typeface="+mn-cs"/>
-              </a:defRPr>
-            </a:lvl6pPr>
-            <a:lvl7pPr marL="2971800" indent="-228600" algn="l" defTabSz="914400" rtl="0" eaLnBrk="1" latinLnBrk="0" hangingPunct="1">
-              <a:lnSpc>
-                <a:spcPct val="90000"/>
-              </a:lnSpc>
-              <a:spcBef>
-                <a:spcPts val="500"/>
-              </a:spcBef>
-              <a:buFont typeface="Arial" panose="020B0604020202020204" pitchFamily="34" charset="0"/>
-              <a:buChar char="•"/>
-              <a:defRPr kumimoji="1" sz="1800" kern="1200">
-                <a:solidFill>
-                  <a:schemeClr val="tx1"/>
-                </a:solidFill>
-                <a:latin typeface="+mn-lt"/>
-                <a:ea typeface="+mn-ea"/>
-                <a:cs typeface="+mn-cs"/>
-              </a:defRPr>
-            </a:lvl7pPr>
-            <a:lvl8pPr marL="3429000" indent="-228600" algn="l" defTabSz="914400" rtl="0" eaLnBrk="1" latinLnBrk="0" hangingPunct="1">
-              <a:lnSpc>
-                <a:spcPct val="90000"/>
-              </a:lnSpc>
-              <a:spcBef>
-                <a:spcPts val="500"/>
-              </a:spcBef>
-              <a:buFont typeface="Arial" panose="020B0604020202020204" pitchFamily="34" charset="0"/>
-              <a:buChar char="•"/>
-              <a:defRPr kumimoji="1" sz="1800" kern="1200">
-                <a:solidFill>
-                  <a:schemeClr val="tx1"/>
-                </a:solidFill>
-                <a:latin typeface="+mn-lt"/>
-                <a:ea typeface="+mn-ea"/>
-                <a:cs typeface="+mn-cs"/>
-              </a:defRPr>
-            </a:lvl8pPr>
-            <a:lvl9pPr marL="3886200" indent="-228600" algn="l" defTabSz="914400" rtl="0" eaLnBrk="1" latinLnBrk="0" hangingPunct="1">
-              <a:lnSpc>
-                <a:spcPct val="90000"/>
-              </a:lnSpc>
-              <a:spcBef>
-                <a:spcPts val="500"/>
-              </a:spcBef>
-              <a:buFont typeface="Arial" panose="020B0604020202020204" pitchFamily="34" charset="0"/>
-              <a:buChar char="•"/>
-              <a:defRPr kumimoji="1" sz="1800" kern="1200">
-                <a:solidFill>
-                  <a:schemeClr val="tx1"/>
-                </a:solidFill>
-                <a:latin typeface="+mn-lt"/>
-                <a:ea typeface="+mn-ea"/>
-                <a:cs typeface="+mn-cs"/>
-              </a:defRPr>
-            </a:lvl9pPr>
-          </a:lstStyle>
-          <a:p>
-            <a:pPr marL="0" indent="0" algn="r">
-              <a:buNone/>
-            </a:pPr>
-            <a:r>
-              <a:rPr lang="en-US" altLang="ja-JP" sz="2400" dirty="0">
-                <a:solidFill>
-                  <a:srgbClr val="000000"/>
-                </a:solidFill>
-                <a:latin typeface="Yu Gothic" panose="020B0400000000000000" pitchFamily="34" charset="-128"/>
-                <a:ea typeface="Yu Gothic" panose="020B0400000000000000" pitchFamily="34" charset="-128"/>
-              </a:rPr>
-              <a:t>※p</a:t>
-            </a:r>
-            <a:r>
-              <a:rPr lang="ja-JP" altLang="en-US" sz="2400">
-                <a:solidFill>
-                  <a:srgbClr val="000000"/>
-                </a:solidFill>
-                <a:latin typeface="Yu Gothic" panose="020B0400000000000000" pitchFamily="34" charset="-128"/>
-                <a:ea typeface="Yu Gothic" panose="020B0400000000000000" pitchFamily="34" charset="-128"/>
-              </a:rPr>
-              <a:t>：人口</a:t>
-            </a:r>
-            <a:r>
-              <a:rPr lang="en-US" altLang="ja-JP" sz="2400" dirty="0">
-                <a:solidFill>
-                  <a:srgbClr val="000000"/>
-                </a:solidFill>
-                <a:latin typeface="Yu Gothic" panose="020B0400000000000000" pitchFamily="34" charset="-128"/>
-                <a:ea typeface="Yu Gothic" panose="020B0400000000000000" pitchFamily="34" charset="-128"/>
-              </a:rPr>
-              <a:t>1</a:t>
-            </a:r>
-            <a:r>
-              <a:rPr lang="ja-JP" altLang="en-US" sz="2400">
-                <a:solidFill>
-                  <a:srgbClr val="000000"/>
-                </a:solidFill>
-                <a:latin typeface="Yu Gothic" panose="020B0400000000000000" pitchFamily="34" charset="-128"/>
-                <a:ea typeface="Yu Gothic" panose="020B0400000000000000" pitchFamily="34" charset="-128"/>
-              </a:rPr>
-              <a:t>人あたり</a:t>
-            </a:r>
-            <a:endParaRPr lang="en-US" altLang="ja-JP" sz="2400" dirty="0">
-              <a:latin typeface="Yu Gothic" panose="020B0400000000000000" pitchFamily="34" charset="-128"/>
-              <a:ea typeface="Yu Gothic" panose="020B0400000000000000" pitchFamily="34" charset="-128"/>
-            </a:endParaRPr>
+            <a:endParaRPr lang="en-US" altLang="ja-JP" sz="2400" dirty="0"/>
           </a:p>
         </p:txBody>
       </p:sp>
@@ -7474,570 +7194,12 @@
             <p:ph idx="1"/>
           </p:nvPr>
         </p:nvSpPr>
-        <p:spPr>
-          <a:xfrm>
-            <a:off x="2640330" y="2210753"/>
-            <a:ext cx="6911340" cy="826135"/>
-          </a:xfrm>
-          <a:ln>
-            <a:solidFill>
-              <a:schemeClr val="tx1"/>
-            </a:solidFill>
-          </a:ln>
-        </p:spPr>
-        <p:txBody>
-          <a:bodyPr anchor="ctr">
-            <a:normAutofit/>
-          </a:bodyPr>
+        <p:spPr/>
+        <p:txBody>
+          <a:bodyPr/>
           <a:lstStyle/>
           <a:p>
-            <a:pPr marL="0" indent="0" algn="ctr">
-              <a:buNone/>
-            </a:pPr>
-            <a:r>
-              <a:rPr kumimoji="1" lang="ja-JP" altLang="en-US"/>
-              <a:t>関係のありそうな説明変数を含めて分析</a:t>
-            </a:r>
-          </a:p>
-        </p:txBody>
-      </p:sp>
-      <p:sp>
-        <p:nvSpPr>
-          <p:cNvPr id="4" name="コンテンツ プレースホルダー 2">
-            <a:extLst>
-              <a:ext uri="{FF2B5EF4-FFF2-40B4-BE49-F238E27FC236}">
-                <a16:creationId xmlns:a16="http://schemas.microsoft.com/office/drawing/2014/main" id="{80A0A63F-02F7-75BC-0C4C-6AAB613A47C9}"/>
-              </a:ext>
-            </a:extLst>
-          </p:cNvPr>
-          <p:cNvSpPr txBox="1">
-            <a:spLocks/>
-          </p:cNvSpPr>
-          <p:nvPr/>
-        </p:nvSpPr>
-        <p:spPr>
-          <a:xfrm>
-            <a:off x="2640330" y="4318586"/>
-            <a:ext cx="6911340" cy="826135"/>
-          </a:xfrm>
-          <a:prstGeom prst="rect">
-            <a:avLst/>
-          </a:prstGeom>
-          <a:ln>
-            <a:solidFill>
-              <a:schemeClr val="tx1"/>
-            </a:solidFill>
-          </a:ln>
-        </p:spPr>
-        <p:txBody>
-          <a:bodyPr vert="horz" lIns="91440" tIns="45720" rIns="91440" bIns="45720" rtlCol="0" anchor="ctr">
-            <a:normAutofit/>
-          </a:bodyPr>
-          <a:lstStyle>
-            <a:lvl1pPr marL="228600" indent="-228600" algn="l" defTabSz="914400" rtl="0" eaLnBrk="1" latinLnBrk="0" hangingPunct="1">
-              <a:lnSpc>
-                <a:spcPct val="90000"/>
-              </a:lnSpc>
-              <a:spcBef>
-                <a:spcPts val="1000"/>
-              </a:spcBef>
-              <a:buFont typeface="Arial" panose="020B0604020202020204" pitchFamily="34" charset="0"/>
-              <a:buChar char="•"/>
-              <a:defRPr kumimoji="1" sz="2800" kern="1200">
-                <a:solidFill>
-                  <a:schemeClr val="tx1"/>
-                </a:solidFill>
-                <a:latin typeface="+mn-lt"/>
-                <a:ea typeface="+mn-ea"/>
-                <a:cs typeface="+mn-cs"/>
-              </a:defRPr>
-            </a:lvl1pPr>
-            <a:lvl2pPr marL="685800" indent="-228600" algn="l" defTabSz="914400" rtl="0" eaLnBrk="1" latinLnBrk="0" hangingPunct="1">
-              <a:lnSpc>
-                <a:spcPct val="90000"/>
-              </a:lnSpc>
-              <a:spcBef>
-                <a:spcPts val="500"/>
-              </a:spcBef>
-              <a:buFont typeface="Arial" panose="020B0604020202020204" pitchFamily="34" charset="0"/>
-              <a:buChar char="•"/>
-              <a:defRPr kumimoji="1" sz="2400" kern="1200">
-                <a:solidFill>
-                  <a:schemeClr val="tx1"/>
-                </a:solidFill>
-                <a:latin typeface="+mn-lt"/>
-                <a:ea typeface="+mn-ea"/>
-                <a:cs typeface="+mn-cs"/>
-              </a:defRPr>
-            </a:lvl2pPr>
-            <a:lvl3pPr marL="1143000" indent="-228600" algn="l" defTabSz="914400" rtl="0" eaLnBrk="1" latinLnBrk="0" hangingPunct="1">
-              <a:lnSpc>
-                <a:spcPct val="90000"/>
-              </a:lnSpc>
-              <a:spcBef>
-                <a:spcPts val="500"/>
-              </a:spcBef>
-              <a:buFont typeface="Arial" panose="020B0604020202020204" pitchFamily="34" charset="0"/>
-              <a:buChar char="•"/>
-              <a:defRPr kumimoji="1" sz="2000" kern="1200">
-                <a:solidFill>
-                  <a:schemeClr val="tx1"/>
-                </a:solidFill>
-                <a:latin typeface="+mn-lt"/>
-                <a:ea typeface="+mn-ea"/>
-                <a:cs typeface="+mn-cs"/>
-              </a:defRPr>
-            </a:lvl3pPr>
-            <a:lvl4pPr marL="1600200" indent="-228600" algn="l" defTabSz="914400" rtl="0" eaLnBrk="1" latinLnBrk="0" hangingPunct="1">
-              <a:lnSpc>
-                <a:spcPct val="90000"/>
-              </a:lnSpc>
-              <a:spcBef>
-                <a:spcPts val="500"/>
-              </a:spcBef>
-              <a:buFont typeface="Arial" panose="020B0604020202020204" pitchFamily="34" charset="0"/>
-              <a:buChar char="•"/>
-              <a:defRPr kumimoji="1" sz="1800" kern="1200">
-                <a:solidFill>
-                  <a:schemeClr val="tx1"/>
-                </a:solidFill>
-                <a:latin typeface="+mn-lt"/>
-                <a:ea typeface="+mn-ea"/>
-                <a:cs typeface="+mn-cs"/>
-              </a:defRPr>
-            </a:lvl4pPr>
-            <a:lvl5pPr marL="2057400" indent="-228600" algn="l" defTabSz="914400" rtl="0" eaLnBrk="1" latinLnBrk="0" hangingPunct="1">
-              <a:lnSpc>
-                <a:spcPct val="90000"/>
-              </a:lnSpc>
-              <a:spcBef>
-                <a:spcPts val="500"/>
-              </a:spcBef>
-              <a:buFont typeface="Arial" panose="020B0604020202020204" pitchFamily="34" charset="0"/>
-              <a:buChar char="•"/>
-              <a:defRPr kumimoji="1" sz="1800" kern="1200">
-                <a:solidFill>
-                  <a:schemeClr val="tx1"/>
-                </a:solidFill>
-                <a:latin typeface="+mn-lt"/>
-                <a:ea typeface="+mn-ea"/>
-                <a:cs typeface="+mn-cs"/>
-              </a:defRPr>
-            </a:lvl5pPr>
-            <a:lvl6pPr marL="2514600" indent="-228600" algn="l" defTabSz="914400" rtl="0" eaLnBrk="1" latinLnBrk="0" hangingPunct="1">
-              <a:lnSpc>
-                <a:spcPct val="90000"/>
-              </a:lnSpc>
-              <a:spcBef>
-                <a:spcPts val="500"/>
-              </a:spcBef>
-              <a:buFont typeface="Arial" panose="020B0604020202020204" pitchFamily="34" charset="0"/>
-              <a:buChar char="•"/>
-              <a:defRPr kumimoji="1" sz="1800" kern="1200">
-                <a:solidFill>
-                  <a:schemeClr val="tx1"/>
-                </a:solidFill>
-                <a:latin typeface="+mn-lt"/>
-                <a:ea typeface="+mn-ea"/>
-                <a:cs typeface="+mn-cs"/>
-              </a:defRPr>
-            </a:lvl6pPr>
-            <a:lvl7pPr marL="2971800" indent="-228600" algn="l" defTabSz="914400" rtl="0" eaLnBrk="1" latinLnBrk="0" hangingPunct="1">
-              <a:lnSpc>
-                <a:spcPct val="90000"/>
-              </a:lnSpc>
-              <a:spcBef>
-                <a:spcPts val="500"/>
-              </a:spcBef>
-              <a:buFont typeface="Arial" panose="020B0604020202020204" pitchFamily="34" charset="0"/>
-              <a:buChar char="•"/>
-              <a:defRPr kumimoji="1" sz="1800" kern="1200">
-                <a:solidFill>
-                  <a:schemeClr val="tx1"/>
-                </a:solidFill>
-                <a:latin typeface="+mn-lt"/>
-                <a:ea typeface="+mn-ea"/>
-                <a:cs typeface="+mn-cs"/>
-              </a:defRPr>
-            </a:lvl7pPr>
-            <a:lvl8pPr marL="3429000" indent="-228600" algn="l" defTabSz="914400" rtl="0" eaLnBrk="1" latinLnBrk="0" hangingPunct="1">
-              <a:lnSpc>
-                <a:spcPct val="90000"/>
-              </a:lnSpc>
-              <a:spcBef>
-                <a:spcPts val="500"/>
-              </a:spcBef>
-              <a:buFont typeface="Arial" panose="020B0604020202020204" pitchFamily="34" charset="0"/>
-              <a:buChar char="•"/>
-              <a:defRPr kumimoji="1" sz="1800" kern="1200">
-                <a:solidFill>
-                  <a:schemeClr val="tx1"/>
-                </a:solidFill>
-                <a:latin typeface="+mn-lt"/>
-                <a:ea typeface="+mn-ea"/>
-                <a:cs typeface="+mn-cs"/>
-              </a:defRPr>
-            </a:lvl8pPr>
-            <a:lvl9pPr marL="3886200" indent="-228600" algn="l" defTabSz="914400" rtl="0" eaLnBrk="1" latinLnBrk="0" hangingPunct="1">
-              <a:lnSpc>
-                <a:spcPct val="90000"/>
-              </a:lnSpc>
-              <a:spcBef>
-                <a:spcPts val="500"/>
-              </a:spcBef>
-              <a:buFont typeface="Arial" panose="020B0604020202020204" pitchFamily="34" charset="0"/>
-              <a:buChar char="•"/>
-              <a:defRPr kumimoji="1" sz="1800" kern="1200">
-                <a:solidFill>
-                  <a:schemeClr val="tx1"/>
-                </a:solidFill>
-                <a:latin typeface="+mn-lt"/>
-                <a:ea typeface="+mn-ea"/>
-                <a:cs typeface="+mn-cs"/>
-              </a:defRPr>
-            </a:lvl9pPr>
-          </a:lstStyle>
-          <a:p>
-            <a:pPr marL="0" indent="0" algn="ctr">
-              <a:buFont typeface="Arial" panose="020B0604020202020204" pitchFamily="34" charset="0"/>
-              <a:buNone/>
-            </a:pPr>
-            <a:r>
-              <a:rPr lang="ja-JP" altLang="en-US"/>
-              <a:t>結果を見て，相関の低い説明変数を消す</a:t>
-            </a:r>
-          </a:p>
-        </p:txBody>
-      </p:sp>
-      <p:sp>
-        <p:nvSpPr>
-          <p:cNvPr id="6" name="曲折矢印 5">
-            <a:extLst>
-              <a:ext uri="{FF2B5EF4-FFF2-40B4-BE49-F238E27FC236}">
-                <a16:creationId xmlns:a16="http://schemas.microsoft.com/office/drawing/2014/main" id="{EBFE7238-4BA3-2AAB-971D-62E9A01D5F0B}"/>
-              </a:ext>
-            </a:extLst>
-          </p:cNvPr>
-          <p:cNvSpPr/>
-          <p:nvPr/>
-        </p:nvSpPr>
-        <p:spPr>
-          <a:xfrm rot="8100000">
-            <a:off x="6287390" y="3273976"/>
-            <a:ext cx="844062" cy="890954"/>
-          </a:xfrm>
-          <a:prstGeom prst="bentArrow">
-            <a:avLst/>
-          </a:prstGeom>
-        </p:spPr>
-        <p:style>
-          <a:lnRef idx="2">
-            <a:schemeClr val="accent1">
-              <a:shade val="15000"/>
-            </a:schemeClr>
-          </a:lnRef>
-          <a:fillRef idx="1">
-            <a:schemeClr val="accent1"/>
-          </a:fillRef>
-          <a:effectRef idx="0">
-            <a:schemeClr val="accent1"/>
-          </a:effectRef>
-          <a:fontRef idx="minor">
-            <a:schemeClr val="lt1"/>
-          </a:fontRef>
-        </p:style>
-        <p:txBody>
-          <a:bodyPr rtlCol="0" anchor="ctr"/>
-          <a:lstStyle/>
-          <a:p>
-            <a:pPr algn="ctr"/>
-            <a:endParaRPr kumimoji="1" lang="ja-JP" altLang="en-US">
-              <a:solidFill>
-                <a:schemeClr val="tx1"/>
-              </a:solidFill>
-            </a:endParaRPr>
-          </a:p>
-        </p:txBody>
-      </p:sp>
-      <p:sp>
-        <p:nvSpPr>
-          <p:cNvPr id="7" name="曲折矢印 6">
-            <a:extLst>
-              <a:ext uri="{FF2B5EF4-FFF2-40B4-BE49-F238E27FC236}">
-                <a16:creationId xmlns:a16="http://schemas.microsoft.com/office/drawing/2014/main" id="{1D5ED781-D534-F420-FE73-CB71090ED591}"/>
-              </a:ext>
-            </a:extLst>
-          </p:cNvPr>
-          <p:cNvSpPr/>
-          <p:nvPr/>
-        </p:nvSpPr>
-        <p:spPr>
-          <a:xfrm rot="8100000" flipH="1" flipV="1">
-            <a:off x="5060548" y="3190544"/>
-            <a:ext cx="844062" cy="890954"/>
-          </a:xfrm>
-          <a:prstGeom prst="bentArrow">
-            <a:avLst/>
-          </a:prstGeom>
-        </p:spPr>
-        <p:style>
-          <a:lnRef idx="2">
-            <a:schemeClr val="accent1">
-              <a:shade val="15000"/>
-            </a:schemeClr>
-          </a:lnRef>
-          <a:fillRef idx="1">
-            <a:schemeClr val="accent1"/>
-          </a:fillRef>
-          <a:effectRef idx="0">
-            <a:schemeClr val="accent1"/>
-          </a:effectRef>
-          <a:fontRef idx="minor">
-            <a:schemeClr val="lt1"/>
-          </a:fontRef>
-        </p:style>
-        <p:txBody>
-          <a:bodyPr rtlCol="0" anchor="ctr"/>
-          <a:lstStyle/>
-          <a:p>
-            <a:pPr algn="ctr"/>
-            <a:endParaRPr kumimoji="1" lang="ja-JP" altLang="en-US">
-              <a:solidFill>
-                <a:schemeClr val="tx1"/>
-              </a:solidFill>
-            </a:endParaRPr>
-          </a:p>
-        </p:txBody>
-      </p:sp>
-      <p:sp>
-        <p:nvSpPr>
-          <p:cNvPr id="9" name="コンテンツ プレースホルダー 2">
-            <a:extLst>
-              <a:ext uri="{FF2B5EF4-FFF2-40B4-BE49-F238E27FC236}">
-                <a16:creationId xmlns:a16="http://schemas.microsoft.com/office/drawing/2014/main" id="{02E72988-66AB-DEF3-52FC-44B90D69C521}"/>
-              </a:ext>
-            </a:extLst>
-          </p:cNvPr>
-          <p:cNvSpPr txBox="1">
-            <a:spLocks/>
-          </p:cNvSpPr>
-          <p:nvPr/>
-        </p:nvSpPr>
-        <p:spPr>
-          <a:xfrm>
-            <a:off x="1729493" y="5745382"/>
-            <a:ext cx="8733014" cy="681037"/>
-          </a:xfrm>
-          <a:prstGeom prst="rect">
-            <a:avLst/>
-          </a:prstGeom>
-        </p:spPr>
-        <p:txBody>
-          <a:bodyPr vert="horz" lIns="91440" tIns="45720" rIns="91440" bIns="45720" rtlCol="0">
-            <a:normAutofit/>
-          </a:bodyPr>
-          <a:lstStyle>
-            <a:lvl1pPr marL="228600" indent="-228600" algn="l" defTabSz="914400" rtl="0" eaLnBrk="1" latinLnBrk="0" hangingPunct="1">
-              <a:lnSpc>
-                <a:spcPct val="90000"/>
-              </a:lnSpc>
-              <a:spcBef>
-                <a:spcPts val="1000"/>
-              </a:spcBef>
-              <a:buFont typeface="Arial" panose="020B0604020202020204" pitchFamily="34" charset="0"/>
-              <a:buChar char="•"/>
-              <a:defRPr kumimoji="1" sz="2800" kern="1200">
-                <a:solidFill>
-                  <a:schemeClr val="tx1"/>
-                </a:solidFill>
-                <a:latin typeface="+mn-lt"/>
-                <a:ea typeface="+mn-ea"/>
-                <a:cs typeface="+mn-cs"/>
-              </a:defRPr>
-            </a:lvl1pPr>
-            <a:lvl2pPr marL="685800" indent="-228600" algn="l" defTabSz="914400" rtl="0" eaLnBrk="1" latinLnBrk="0" hangingPunct="1">
-              <a:lnSpc>
-                <a:spcPct val="90000"/>
-              </a:lnSpc>
-              <a:spcBef>
-                <a:spcPts val="500"/>
-              </a:spcBef>
-              <a:buFont typeface="Arial" panose="020B0604020202020204" pitchFamily="34" charset="0"/>
-              <a:buChar char="•"/>
-              <a:defRPr kumimoji="1" sz="2400" kern="1200">
-                <a:solidFill>
-                  <a:schemeClr val="tx1"/>
-                </a:solidFill>
-                <a:latin typeface="+mn-lt"/>
-                <a:ea typeface="+mn-ea"/>
-                <a:cs typeface="+mn-cs"/>
-              </a:defRPr>
-            </a:lvl2pPr>
-            <a:lvl3pPr marL="1143000" indent="-228600" algn="l" defTabSz="914400" rtl="0" eaLnBrk="1" latinLnBrk="0" hangingPunct="1">
-              <a:lnSpc>
-                <a:spcPct val="90000"/>
-              </a:lnSpc>
-              <a:spcBef>
-                <a:spcPts val="500"/>
-              </a:spcBef>
-              <a:buFont typeface="Arial" panose="020B0604020202020204" pitchFamily="34" charset="0"/>
-              <a:buChar char="•"/>
-              <a:defRPr kumimoji="1" sz="2000" kern="1200">
-                <a:solidFill>
-                  <a:schemeClr val="tx1"/>
-                </a:solidFill>
-                <a:latin typeface="+mn-lt"/>
-                <a:ea typeface="+mn-ea"/>
-                <a:cs typeface="+mn-cs"/>
-              </a:defRPr>
-            </a:lvl3pPr>
-            <a:lvl4pPr marL="1600200" indent="-228600" algn="l" defTabSz="914400" rtl="0" eaLnBrk="1" latinLnBrk="0" hangingPunct="1">
-              <a:lnSpc>
-                <a:spcPct val="90000"/>
-              </a:lnSpc>
-              <a:spcBef>
-                <a:spcPts val="500"/>
-              </a:spcBef>
-              <a:buFont typeface="Arial" panose="020B0604020202020204" pitchFamily="34" charset="0"/>
-              <a:buChar char="•"/>
-              <a:defRPr kumimoji="1" sz="1800" kern="1200">
-                <a:solidFill>
-                  <a:schemeClr val="tx1"/>
-                </a:solidFill>
-                <a:latin typeface="+mn-lt"/>
-                <a:ea typeface="+mn-ea"/>
-                <a:cs typeface="+mn-cs"/>
-              </a:defRPr>
-            </a:lvl4pPr>
-            <a:lvl5pPr marL="2057400" indent="-228600" algn="l" defTabSz="914400" rtl="0" eaLnBrk="1" latinLnBrk="0" hangingPunct="1">
-              <a:lnSpc>
-                <a:spcPct val="90000"/>
-              </a:lnSpc>
-              <a:spcBef>
-                <a:spcPts val="500"/>
-              </a:spcBef>
-              <a:buFont typeface="Arial" panose="020B0604020202020204" pitchFamily="34" charset="0"/>
-              <a:buChar char="•"/>
-              <a:defRPr kumimoji="1" sz="1800" kern="1200">
-                <a:solidFill>
-                  <a:schemeClr val="tx1"/>
-                </a:solidFill>
-                <a:latin typeface="+mn-lt"/>
-                <a:ea typeface="+mn-ea"/>
-                <a:cs typeface="+mn-cs"/>
-              </a:defRPr>
-            </a:lvl5pPr>
-            <a:lvl6pPr marL="2514600" indent="-228600" algn="l" defTabSz="914400" rtl="0" eaLnBrk="1" latinLnBrk="0" hangingPunct="1">
-              <a:lnSpc>
-                <a:spcPct val="90000"/>
-              </a:lnSpc>
-              <a:spcBef>
-                <a:spcPts val="500"/>
-              </a:spcBef>
-              <a:buFont typeface="Arial" panose="020B0604020202020204" pitchFamily="34" charset="0"/>
-              <a:buChar char="•"/>
-              <a:defRPr kumimoji="1" sz="1800" kern="1200">
-                <a:solidFill>
-                  <a:schemeClr val="tx1"/>
-                </a:solidFill>
-                <a:latin typeface="+mn-lt"/>
-                <a:ea typeface="+mn-ea"/>
-                <a:cs typeface="+mn-cs"/>
-              </a:defRPr>
-            </a:lvl6pPr>
-            <a:lvl7pPr marL="2971800" indent="-228600" algn="l" defTabSz="914400" rtl="0" eaLnBrk="1" latinLnBrk="0" hangingPunct="1">
-              <a:lnSpc>
-                <a:spcPct val="90000"/>
-              </a:lnSpc>
-              <a:spcBef>
-                <a:spcPts val="500"/>
-              </a:spcBef>
-              <a:buFont typeface="Arial" panose="020B0604020202020204" pitchFamily="34" charset="0"/>
-              <a:buChar char="•"/>
-              <a:defRPr kumimoji="1" sz="1800" kern="1200">
-                <a:solidFill>
-                  <a:schemeClr val="tx1"/>
-                </a:solidFill>
-                <a:latin typeface="+mn-lt"/>
-                <a:ea typeface="+mn-ea"/>
-                <a:cs typeface="+mn-cs"/>
-              </a:defRPr>
-            </a:lvl7pPr>
-            <a:lvl8pPr marL="3429000" indent="-228600" algn="l" defTabSz="914400" rtl="0" eaLnBrk="1" latinLnBrk="0" hangingPunct="1">
-              <a:lnSpc>
-                <a:spcPct val="90000"/>
-              </a:lnSpc>
-              <a:spcBef>
-                <a:spcPts val="500"/>
-              </a:spcBef>
-              <a:buFont typeface="Arial" panose="020B0604020202020204" pitchFamily="34" charset="0"/>
-              <a:buChar char="•"/>
-              <a:defRPr kumimoji="1" sz="1800" kern="1200">
-                <a:solidFill>
-                  <a:schemeClr val="tx1"/>
-                </a:solidFill>
-                <a:latin typeface="+mn-lt"/>
-                <a:ea typeface="+mn-ea"/>
-                <a:cs typeface="+mn-cs"/>
-              </a:defRPr>
-            </a:lvl8pPr>
-            <a:lvl9pPr marL="3886200" indent="-228600" algn="l" defTabSz="914400" rtl="0" eaLnBrk="1" latinLnBrk="0" hangingPunct="1">
-              <a:lnSpc>
-                <a:spcPct val="90000"/>
-              </a:lnSpc>
-              <a:spcBef>
-                <a:spcPts val="500"/>
-              </a:spcBef>
-              <a:buFont typeface="Arial" panose="020B0604020202020204" pitchFamily="34" charset="0"/>
-              <a:buChar char="•"/>
-              <a:defRPr kumimoji="1" sz="1800" kern="1200">
-                <a:solidFill>
-                  <a:schemeClr val="tx1"/>
-                </a:solidFill>
-                <a:latin typeface="+mn-lt"/>
-                <a:ea typeface="+mn-ea"/>
-                <a:cs typeface="+mn-cs"/>
-              </a:defRPr>
-            </a:lvl9pPr>
-          </a:lstStyle>
-          <a:p>
-            <a:pPr marL="0" indent="0" algn="ctr">
-              <a:buNone/>
-            </a:pPr>
-            <a:r>
-              <a:rPr lang="ja-JP" altLang="en-US">
-                <a:solidFill>
-                  <a:srgbClr val="000000"/>
-                </a:solidFill>
-                <a:latin typeface="Yu Gothic" panose="020B0400000000000000" pitchFamily="34" charset="-128"/>
-                <a:ea typeface="Yu Gothic" panose="020B0400000000000000" pitchFamily="34" charset="-128"/>
-              </a:rPr>
-              <a:t>→最終的に計</a:t>
-            </a:r>
-            <a:r>
-              <a:rPr lang="en-US" altLang="ja-JP" dirty="0">
-                <a:solidFill>
-                  <a:srgbClr val="000000"/>
-                </a:solidFill>
-                <a:latin typeface="Yu Gothic" panose="020B0400000000000000" pitchFamily="34" charset="-128"/>
-                <a:ea typeface="Yu Gothic" panose="020B0400000000000000" pitchFamily="34" charset="-128"/>
-              </a:rPr>
-              <a:t>54</a:t>
-            </a:r>
-            <a:r>
-              <a:rPr lang="ja-JP" altLang="en-US">
-                <a:solidFill>
-                  <a:srgbClr val="000000"/>
-                </a:solidFill>
-                <a:latin typeface="Yu Gothic" panose="020B0400000000000000" pitchFamily="34" charset="-128"/>
-                <a:ea typeface="Yu Gothic" panose="020B0400000000000000" pitchFamily="34" charset="-128"/>
-              </a:rPr>
-              <a:t>回の重回帰分析を試行</a:t>
-            </a:r>
-            <a:endParaRPr lang="en-US" altLang="ja-JP" dirty="0">
-              <a:latin typeface="Yu Gothic" panose="020B0400000000000000" pitchFamily="34" charset="-128"/>
-              <a:ea typeface="Yu Gothic" panose="020B0400000000000000" pitchFamily="34" charset="-128"/>
-            </a:endParaRPr>
+            <a:endParaRPr kumimoji="1" lang="ja-JP" altLang="en-US"/>
           </a:p>
         </p:txBody>
       </p:sp>

</xml_diff>